<commit_message>
Atualiza apresentacao: M0-M4 concluidos + slide de avaliacao
Reflete o estado atual (API completa no ar, CI passando) e inclui as metricas
da avaliacao inicial. Roadmap com M1-M4 marcados como concluidos.

Co-Authored-By: Claude Opus 4.8 <noreply@anthropic.com>
</commit_message>
<xml_diff>
--- a/docs/apresentacao/Localizacao-Indoor-Teto.pptx
+++ b/docs/apresentacao/Localizacao-Indoor-Teto.pptx
@@ -17,6 +17,7 @@
     <p:sldId id="265" r:id="rId16"/>
     <p:sldId id="266" r:id="rId17"/>
     <p:sldId id="267" r:id="rId18"/>
+    <p:sldId id="268" r:id="rId19"/>
   </p:sldIdLst>
   <p:sldSz cx="12191695" cy="6858000" type="screen4x3"/>
   <p:notesSz cx="6858000" cy="9144000"/>
@@ -3245,7 +3246,7 @@
               </a:defRPr>
             </a:pPr>
             <a:r>
-              <a:t>Status atual — M0 concluído ✓</a:t>
+              <a:t>Status atual — M0 a M4 concluídos ✓</a:t>
             </a:r>
           </a:p>
         </p:txBody>
@@ -3283,7 +3284,7 @@
               </a:defRPr>
             </a:pPr>
             <a:r>
-              <a:t>• Repositório, estrutura e documentação (em português) prontos.</a:t>
+              <a:t>• API completa no ar no gimli: /saude, /locais, /plantas, /fotos, /localizar.</a:t>
             </a:r>
           </a:p>
           <a:p>
@@ -3298,7 +3299,7 @@
               </a:defRPr>
             </a:pPr>
             <a:r>
-              <a:t>• Backend FastAPI no ar no gimli: /saude → banco 'ok'.</a:t>
+              <a:t>• Banco 'teto' com pgvector + earthdistance; tabelas e índices via Alembic.</a:t>
             </a:r>
           </a:p>
           <a:p>
@@ -3313,7 +3314,7 @@
               </a:defRPr>
             </a:pPr>
             <a:r>
-              <a:t>• Banco 'teto' criado com extensões vector, cube, earthdistance.</a:t>
+              <a:t>• Coleta grava foto + GPS + (x,y) + embedding; consulta retorna (x,y) + confiança.</a:t>
             </a:r>
           </a:p>
           <a:p>
@@ -3328,7 +3329,7 @@
               </a:defRPr>
             </a:pPr>
             <a:r>
-              <a:t>• Tabelas local, planta, foto + índices (HNSW, GiST) via migração Alembic.</a:t>
+              <a:t>• Apps Vue (admin, coletor, teste) integrados com câmera, GPS e planta.</a:t>
             </a:r>
           </a:p>
           <a:p>
@@ -3343,7 +3344,7 @@
               </a:defRPr>
             </a:pPr>
             <a:r>
-              <a:t>• Apps Vue (admin, coletor, teste) com estrutura e integração câmera/GPS.</a:t>
+              <a:t>• CI no ar (GitHub Actions) com lint + testes; deploy automatizado por script.</a:t>
             </a:r>
           </a:p>
           <a:p>
@@ -3358,7 +3359,7 @@
               </a:defRPr>
             </a:pPr>
             <a:r>
-              <a:t>   – Acessível em teto.local (Traefik); Cloudflare Tunnel a configurar.</a:t>
+              <a:t>   – Pendente: expor via Cloudflare Tunnel (depende do painel Cloudflare).</a:t>
             </a:r>
           </a:p>
         </p:txBody>
@@ -3372,6 +3373,341 @@
 </file>
 
 <file path=ppt/slides/slide11.xml><?xml version="1.0" encoding="utf-8"?>
+<p:sld xmlns:a="http://schemas.openxmlformats.org/drawingml/2006/main" xmlns:p="http://schemas.openxmlformats.org/presentationml/2006/main" xmlns:r="http://schemas.openxmlformats.org/officeDocument/2006/relationships">
+  <p:cSld>
+    <p:bg>
+      <p:bgPr>
+        <a:solidFill>
+          <a:srgbClr val="FFFFFF"/>
+        </a:solidFill>
+        <a:effectLst/>
+      </p:bgPr>
+    </p:bg>
+    <p:spTree>
+      <p:nvGrpSpPr>
+        <p:cNvPr id="1" name=""/>
+        <p:cNvGrpSpPr/>
+        <p:nvPr/>
+      </p:nvGrpSpPr>
+      <p:grpSpPr/>
+      <p:sp>
+        <p:nvSpPr>
+          <p:cNvPr id="2" name="TextBox 1"/>
+          <p:cNvSpPr txBox="1"/>
+          <p:nvPr/>
+        </p:nvSpPr>
+        <p:spPr>
+          <a:xfrm>
+            <a:off x="640080" y="457200"/>
+            <a:ext cx="10972800" cy="914400"/>
+          </a:xfrm>
+          <a:prstGeom prst="rect">
+            <a:avLst/>
+          </a:prstGeom>
+          <a:noFill/>
+        </p:spPr>
+        <p:txBody>
+          <a:bodyPr wrap="square">
+            <a:spAutoFit/>
+          </a:bodyPr>
+          <a:lstStyle/>
+          <a:p>
+            <a:pPr>
+              <a:defRPr sz="3200" b="1">
+                <a:solidFill>
+                  <a:srgbClr val="2563EB"/>
+                </a:solidFill>
+              </a:defRPr>
+            </a:pPr>
+            <a:r>
+              <a:t>Avaliação inicial (cenário sintético)</a:t>
+            </a:r>
+          </a:p>
+        </p:txBody>
+      </p:sp>
+      <p:graphicFrame>
+        <p:nvGraphicFramePr>
+          <p:cNvPr id="3" name="Table 2"/>
+          <p:cNvGraphicFramePr>
+            <a:graphicFrameLocks noGrp="1"/>
+          </p:cNvGraphicFramePr>
+          <p:nvPr/>
+        </p:nvGraphicFramePr>
+        <p:xfrm>
+          <a:off x="640080" y="1554480"/>
+          <a:ext cx="10972800" cy="2194560"/>
+        </p:xfrm>
+        <a:graphic>
+          <a:graphicData uri="http://schemas.openxmlformats.org/drawingml/2006/table">
+            <a:tbl>
+              <a:tblPr firstRow="1" bandRow="1">
+                <a:tableStyleId>{5C22544A-7EE6-4342-B048-85BDC9FD1C3A}</a:tableStyleId>
+              </a:tblPr>
+              <a:tblGrid>
+                <a:gridCol w="5486400"/>
+                <a:gridCol w="5486400"/>
+              </a:tblGrid>
+              <a:tr h="365760">
+                <a:tc>
+                  <a:txBody>
+                    <a:bodyPr/>
+                    <a:lstStyle/>
+                    <a:p>
+                      <a:pPr>
+                        <a:defRPr b="1" sz="1600">
+                          <a:solidFill>
+                            <a:srgbClr val="FFFFFF"/>
+                          </a:solidFill>
+                        </a:defRPr>
+                      </a:pPr>
+                      <a:r>
+                        <a:t>Métrica</a:t>
+                      </a:r>
+                    </a:p>
+                  </a:txBody>
+                  <a:tcPr>
+                    <a:solidFill>
+                      <a:srgbClr val="1F2937"/>
+                    </a:solidFill>
+                  </a:tcPr>
+                </a:tc>
+                <a:tc>
+                  <a:txBody>
+                    <a:bodyPr/>
+                    <a:lstStyle/>
+                    <a:p>
+                      <a:pPr>
+                        <a:defRPr b="1" sz="1600">
+                          <a:solidFill>
+                            <a:srgbClr val="FFFFFF"/>
+                          </a:solidFill>
+                        </a:defRPr>
+                      </a:pPr>
+                      <a:r>
+                        <a:t>Valor</a:t>
+                      </a:r>
+                    </a:p>
+                  </a:txBody>
+                  <a:tcPr>
+                    <a:solidFill>
+                      <a:srgbClr val="1F2937"/>
+                    </a:solidFill>
+                  </a:tcPr>
+                </a:tc>
+              </a:tr>
+              <a:tr h="365760">
+                <a:tc>
+                  <a:txBody>
+                    <a:bodyPr/>
+                    <a:lstStyle/>
+                    <a:p>
+                      <a:pPr>
+                        <a:defRPr sz="1400">
+                          <a:solidFill>
+                            <a:srgbClr val="111827"/>
+                          </a:solidFill>
+                        </a:defRPr>
+                      </a:pPr>
+                      <a:r>
+                        <a:t>Posições mapeadas</a:t>
+                      </a:r>
+                    </a:p>
+                  </a:txBody>
+                  <a:tcPr/>
+                </a:tc>
+                <a:tc>
+                  <a:txBody>
+                    <a:bodyPr/>
+                    <a:lstStyle/>
+                    <a:p>
+                      <a:pPr>
+                        <a:defRPr sz="1400">
+                          <a:solidFill>
+                            <a:srgbClr val="111827"/>
+                          </a:solidFill>
+                        </a:defRPr>
+                      </a:pPr>
+                      <a:r>
+                        <a:t>25 (planta de ~50 m)</a:t>
+                      </a:r>
+                    </a:p>
+                  </a:txBody>
+                  <a:tcPr/>
+                </a:tc>
+              </a:tr>
+              <a:tr h="365760">
+                <a:tc>
+                  <a:txBody>
+                    <a:bodyPr/>
+                    <a:lstStyle/>
+                    <a:p>
+                      <a:pPr>
+                        <a:defRPr sz="1400">
+                          <a:solidFill>
+                            <a:srgbClr val="111827"/>
+                          </a:solidFill>
+                        </a:defRPr>
+                      </a:pPr>
+                      <a:r>
+                        <a:t>Erro mediano</a:t>
+                      </a:r>
+                    </a:p>
+                  </a:txBody>
+                  <a:tcPr/>
+                </a:tc>
+                <a:tc>
+                  <a:txBody>
+                    <a:bodyPr/>
+                    <a:lstStyle/>
+                    <a:p>
+                      <a:pPr>
+                        <a:defRPr sz="1400">
+                          <a:solidFill>
+                            <a:srgbClr val="111827"/>
+                          </a:solidFill>
+                        </a:defRPr>
+                      </a:pPr>
+                      <a:r>
+                        <a:t>~0,6 m</a:t>
+                      </a:r>
+                    </a:p>
+                  </a:txBody>
+                  <a:tcPr/>
+                </a:tc>
+              </a:tr>
+              <a:tr h="365760">
+                <a:tc>
+                  <a:txBody>
+                    <a:bodyPr/>
+                    <a:lstStyle/>
+                    <a:p>
+                      <a:pPr>
+                        <a:defRPr sz="1400">
+                          <a:solidFill>
+                            <a:srgbClr val="111827"/>
+                          </a:solidFill>
+                        </a:defRPr>
+                      </a:pPr>
+                      <a:r>
+                        <a:t>Erro máximo</a:t>
+                      </a:r>
+                    </a:p>
+                  </a:txBody>
+                  <a:tcPr/>
+                </a:tc>
+                <a:tc>
+                  <a:txBody>
+                    <a:bodyPr/>
+                    <a:lstStyle/>
+                    <a:p>
+                      <a:pPr>
+                        <a:defRPr sz="1400">
+                          <a:solidFill>
+                            <a:srgbClr val="111827"/>
+                          </a:solidFill>
+                        </a:defRPr>
+                      </a:pPr>
+                      <a:r>
+                        <a:t>~0,95 m</a:t>
+                      </a:r>
+                    </a:p>
+                  </a:txBody>
+                  <a:tcPr/>
+                </a:tc>
+              </a:tr>
+              <a:tr h="365760">
+                <a:tc>
+                  <a:txBody>
+                    <a:bodyPr/>
+                    <a:lstStyle/>
+                    <a:p>
+                      <a:pPr>
+                        <a:defRPr sz="1400">
+                          <a:solidFill>
+                            <a:srgbClr val="111827"/>
+                          </a:solidFill>
+                        </a:defRPr>
+                      </a:pPr>
+                      <a:r>
+                        <a:t>Taxa de acerto (≤ 2 m)</a:t>
+                      </a:r>
+                    </a:p>
+                  </a:txBody>
+                  <a:tcPr/>
+                </a:tc>
+                <a:tc>
+                  <a:txBody>
+                    <a:bodyPr/>
+                    <a:lstStyle/>
+                    <a:p>
+                      <a:pPr>
+                        <a:defRPr sz="1400">
+                          <a:solidFill>
+                            <a:srgbClr val="111827"/>
+                          </a:solidFill>
+                        </a:defRPr>
+                      </a:pPr>
+                      <a:r>
+                        <a:t>100%</a:t>
+                      </a:r>
+                    </a:p>
+                  </a:txBody>
+                  <a:tcPr/>
+                </a:tc>
+              </a:tr>
+              <a:tr h="365760">
+                <a:tc>
+                  <a:txBody>
+                    <a:bodyPr/>
+                    <a:lstStyle/>
+                    <a:p>
+                      <a:pPr>
+                        <a:defRPr sz="1400">
+                          <a:solidFill>
+                            <a:srgbClr val="111827"/>
+                          </a:solidFill>
+                        </a:defRPr>
+                      </a:pPr>
+                      <a:r>
+                        <a:t>Backend de embedding</a:t>
+                      </a:r>
+                    </a:p>
+                  </a:txBody>
+                  <a:tcPr/>
+                </a:tc>
+                <a:tc>
+                  <a:txBody>
+                    <a:bodyPr/>
+                    <a:lstStyle/>
+                    <a:p>
+                      <a:pPr>
+                        <a:defRPr sz="1400">
+                          <a:solidFill>
+                            <a:srgbClr val="111827"/>
+                          </a:solidFill>
+                        </a:defRPr>
+                      </a:pPr>
+                      <a:r>
+                        <a:t>tiny-image (512-d); DINOv2 plugável (M+)</a:t>
+                      </a:r>
+                    </a:p>
+                  </a:txBody>
+                  <a:tcPr/>
+                </a:tc>
+              </a:tr>
+            </a:tbl>
+          </a:graphicData>
+        </a:graphic>
+      </p:graphicFrame>
+    </p:spTree>
+  </p:cSld>
+  <p:clrMapOvr>
+    <a:masterClrMapping/>
+  </p:clrMapOvr>
+</p:sld>
+</file>
+
+<file path=ppt/slides/slide12.xml><?xml version="1.0" encoding="utf-8"?>
 <p:sld xmlns:a="http://schemas.openxmlformats.org/drawingml/2006/main" xmlns:p="http://schemas.openxmlformats.org/presentationml/2006/main" xmlns:r="http://schemas.openxmlformats.org/officeDocument/2006/relationships">
   <p:cSld>
     <p:bg>
@@ -3548,7 +3884,7 @@
                         </a:defRPr>
                       </a:pPr>
                       <a:r>
-                        <a:t>M1</a:t>
+                        <a:t>M1 ✓</a:t>
                       </a:r>
                     </a:p>
                   </a:txBody>
@@ -3588,7 +3924,7 @@
                         </a:defRPr>
                       </a:pPr>
                       <a:r>
-                        <a:t>M2</a:t>
+                        <a:t>M2 ✓</a:t>
                       </a:r>
                     </a:p>
                   </a:txBody>
@@ -3628,7 +3964,7 @@
                         </a:defRPr>
                       </a:pPr>
                       <a:r>
-                        <a:t>M3</a:t>
+                        <a:t>M3 ✓</a:t>
                       </a:r>
                     </a:p>
                   </a:txBody>
@@ -3668,7 +4004,7 @@
                         </a:defRPr>
                       </a:pPr>
                       <a:r>
-                        <a:t>M4</a:t>
+                        <a:t>M4 ✓</a:t>
                       </a:r>
                     </a:p>
                   </a:txBody>
@@ -3687,7 +4023,7 @@
                         </a:defRPr>
                       </a:pPr>
                       <a:r>
-                        <a:t>Avaliação: métricas de erro (metros) e ajuste do modelo</a:t>
+                        <a:t>Avaliação: métricas de erro (metros) e relatório</a:t>
                       </a:r>
                     </a:p>
                   </a:txBody>
@@ -3706,7 +4042,7 @@
 </p:sld>
 </file>
 
-<file path=ppt/slides/slide12.xml><?xml version="1.0" encoding="utf-8"?>
+<file path=ppt/slides/slide13.xml><?xml version="1.0" encoding="utf-8"?>
 <p:sld xmlns:a="http://schemas.openxmlformats.org/drawingml/2006/main" xmlns:p="http://schemas.openxmlformats.org/presentationml/2006/main" xmlns:r="http://schemas.openxmlformats.org/officeDocument/2006/relationships">
   <p:cSld>
     <p:bg>
@@ -3754,7 +4090,7 @@
               </a:defRPr>
             </a:pPr>
             <a:r>
-              <a:t>Obrigado!  Próximo passo: M1 — Cadastro de locais e plantas</a:t>
+              <a:t>Obrigado!  Próximos passos: Cloudflare Tunnel, embeddings fortes e dados reais</a:t>
             </a:r>
           </a:p>
         </p:txBody>

</xml_diff>

<commit_message>
Atualiza apresentacao: M0-M4 concluidos + slide de avaliacao (#17)
Reflete o estado atual (API completa no ar, CI passando) e inclui as metricas
da avaliacao inicial. Roadmap com M1-M4 marcados como concluidos.

Co-authored-by: muniagebot <muniagebot@users.noreply.github.com>
Co-authored-by: Claude Opus 4.8 <noreply@anthropic.com>
</commit_message>
<xml_diff>
--- a/docs/apresentacao/Localizacao-Indoor-Teto.pptx
+++ b/docs/apresentacao/Localizacao-Indoor-Teto.pptx
@@ -17,6 +17,7 @@
     <p:sldId id="265" r:id="rId16"/>
     <p:sldId id="266" r:id="rId17"/>
     <p:sldId id="267" r:id="rId18"/>
+    <p:sldId id="268" r:id="rId19"/>
   </p:sldIdLst>
   <p:sldSz cx="12191695" cy="6858000" type="screen4x3"/>
   <p:notesSz cx="6858000" cy="9144000"/>
@@ -3245,7 +3246,7 @@
               </a:defRPr>
             </a:pPr>
             <a:r>
-              <a:t>Status atual — M0 concluído ✓</a:t>
+              <a:t>Status atual — M0 a M4 concluídos ✓</a:t>
             </a:r>
           </a:p>
         </p:txBody>
@@ -3283,7 +3284,7 @@
               </a:defRPr>
             </a:pPr>
             <a:r>
-              <a:t>• Repositório, estrutura e documentação (em português) prontos.</a:t>
+              <a:t>• API completa no ar no gimli: /saude, /locais, /plantas, /fotos, /localizar.</a:t>
             </a:r>
           </a:p>
           <a:p>
@@ -3298,7 +3299,7 @@
               </a:defRPr>
             </a:pPr>
             <a:r>
-              <a:t>• Backend FastAPI no ar no gimli: /saude → banco 'ok'.</a:t>
+              <a:t>• Banco 'teto' com pgvector + earthdistance; tabelas e índices via Alembic.</a:t>
             </a:r>
           </a:p>
           <a:p>
@@ -3313,7 +3314,7 @@
               </a:defRPr>
             </a:pPr>
             <a:r>
-              <a:t>• Banco 'teto' criado com extensões vector, cube, earthdistance.</a:t>
+              <a:t>• Coleta grava foto + GPS + (x,y) + embedding; consulta retorna (x,y) + confiança.</a:t>
             </a:r>
           </a:p>
           <a:p>
@@ -3328,7 +3329,7 @@
               </a:defRPr>
             </a:pPr>
             <a:r>
-              <a:t>• Tabelas local, planta, foto + índices (HNSW, GiST) via migração Alembic.</a:t>
+              <a:t>• Apps Vue (admin, coletor, teste) integrados com câmera, GPS e planta.</a:t>
             </a:r>
           </a:p>
           <a:p>
@@ -3343,7 +3344,7 @@
               </a:defRPr>
             </a:pPr>
             <a:r>
-              <a:t>• Apps Vue (admin, coletor, teste) com estrutura e integração câmera/GPS.</a:t>
+              <a:t>• CI no ar (GitHub Actions) com lint + testes; deploy automatizado por script.</a:t>
             </a:r>
           </a:p>
           <a:p>
@@ -3358,7 +3359,7 @@
               </a:defRPr>
             </a:pPr>
             <a:r>
-              <a:t>   – Acessível em teto.local (Traefik); Cloudflare Tunnel a configurar.</a:t>
+              <a:t>   – Pendente: expor via Cloudflare Tunnel (depende do painel Cloudflare).</a:t>
             </a:r>
           </a:p>
         </p:txBody>
@@ -3372,6 +3373,341 @@
 </file>
 
 <file path=ppt/slides/slide11.xml><?xml version="1.0" encoding="utf-8"?>
+<p:sld xmlns:a="http://schemas.openxmlformats.org/drawingml/2006/main" xmlns:p="http://schemas.openxmlformats.org/presentationml/2006/main" xmlns:r="http://schemas.openxmlformats.org/officeDocument/2006/relationships">
+  <p:cSld>
+    <p:bg>
+      <p:bgPr>
+        <a:solidFill>
+          <a:srgbClr val="FFFFFF"/>
+        </a:solidFill>
+        <a:effectLst/>
+      </p:bgPr>
+    </p:bg>
+    <p:spTree>
+      <p:nvGrpSpPr>
+        <p:cNvPr id="1" name=""/>
+        <p:cNvGrpSpPr/>
+        <p:nvPr/>
+      </p:nvGrpSpPr>
+      <p:grpSpPr/>
+      <p:sp>
+        <p:nvSpPr>
+          <p:cNvPr id="2" name="TextBox 1"/>
+          <p:cNvSpPr txBox="1"/>
+          <p:nvPr/>
+        </p:nvSpPr>
+        <p:spPr>
+          <a:xfrm>
+            <a:off x="640080" y="457200"/>
+            <a:ext cx="10972800" cy="914400"/>
+          </a:xfrm>
+          <a:prstGeom prst="rect">
+            <a:avLst/>
+          </a:prstGeom>
+          <a:noFill/>
+        </p:spPr>
+        <p:txBody>
+          <a:bodyPr wrap="square">
+            <a:spAutoFit/>
+          </a:bodyPr>
+          <a:lstStyle/>
+          <a:p>
+            <a:pPr>
+              <a:defRPr sz="3200" b="1">
+                <a:solidFill>
+                  <a:srgbClr val="2563EB"/>
+                </a:solidFill>
+              </a:defRPr>
+            </a:pPr>
+            <a:r>
+              <a:t>Avaliação inicial (cenário sintético)</a:t>
+            </a:r>
+          </a:p>
+        </p:txBody>
+      </p:sp>
+      <p:graphicFrame>
+        <p:nvGraphicFramePr>
+          <p:cNvPr id="3" name="Table 2"/>
+          <p:cNvGraphicFramePr>
+            <a:graphicFrameLocks noGrp="1"/>
+          </p:cNvGraphicFramePr>
+          <p:nvPr/>
+        </p:nvGraphicFramePr>
+        <p:xfrm>
+          <a:off x="640080" y="1554480"/>
+          <a:ext cx="10972800" cy="2194560"/>
+        </p:xfrm>
+        <a:graphic>
+          <a:graphicData uri="http://schemas.openxmlformats.org/drawingml/2006/table">
+            <a:tbl>
+              <a:tblPr firstRow="1" bandRow="1">
+                <a:tableStyleId>{5C22544A-7EE6-4342-B048-85BDC9FD1C3A}</a:tableStyleId>
+              </a:tblPr>
+              <a:tblGrid>
+                <a:gridCol w="5486400"/>
+                <a:gridCol w="5486400"/>
+              </a:tblGrid>
+              <a:tr h="365760">
+                <a:tc>
+                  <a:txBody>
+                    <a:bodyPr/>
+                    <a:lstStyle/>
+                    <a:p>
+                      <a:pPr>
+                        <a:defRPr b="1" sz="1600">
+                          <a:solidFill>
+                            <a:srgbClr val="FFFFFF"/>
+                          </a:solidFill>
+                        </a:defRPr>
+                      </a:pPr>
+                      <a:r>
+                        <a:t>Métrica</a:t>
+                      </a:r>
+                    </a:p>
+                  </a:txBody>
+                  <a:tcPr>
+                    <a:solidFill>
+                      <a:srgbClr val="1F2937"/>
+                    </a:solidFill>
+                  </a:tcPr>
+                </a:tc>
+                <a:tc>
+                  <a:txBody>
+                    <a:bodyPr/>
+                    <a:lstStyle/>
+                    <a:p>
+                      <a:pPr>
+                        <a:defRPr b="1" sz="1600">
+                          <a:solidFill>
+                            <a:srgbClr val="FFFFFF"/>
+                          </a:solidFill>
+                        </a:defRPr>
+                      </a:pPr>
+                      <a:r>
+                        <a:t>Valor</a:t>
+                      </a:r>
+                    </a:p>
+                  </a:txBody>
+                  <a:tcPr>
+                    <a:solidFill>
+                      <a:srgbClr val="1F2937"/>
+                    </a:solidFill>
+                  </a:tcPr>
+                </a:tc>
+              </a:tr>
+              <a:tr h="365760">
+                <a:tc>
+                  <a:txBody>
+                    <a:bodyPr/>
+                    <a:lstStyle/>
+                    <a:p>
+                      <a:pPr>
+                        <a:defRPr sz="1400">
+                          <a:solidFill>
+                            <a:srgbClr val="111827"/>
+                          </a:solidFill>
+                        </a:defRPr>
+                      </a:pPr>
+                      <a:r>
+                        <a:t>Posições mapeadas</a:t>
+                      </a:r>
+                    </a:p>
+                  </a:txBody>
+                  <a:tcPr/>
+                </a:tc>
+                <a:tc>
+                  <a:txBody>
+                    <a:bodyPr/>
+                    <a:lstStyle/>
+                    <a:p>
+                      <a:pPr>
+                        <a:defRPr sz="1400">
+                          <a:solidFill>
+                            <a:srgbClr val="111827"/>
+                          </a:solidFill>
+                        </a:defRPr>
+                      </a:pPr>
+                      <a:r>
+                        <a:t>25 (planta de ~50 m)</a:t>
+                      </a:r>
+                    </a:p>
+                  </a:txBody>
+                  <a:tcPr/>
+                </a:tc>
+              </a:tr>
+              <a:tr h="365760">
+                <a:tc>
+                  <a:txBody>
+                    <a:bodyPr/>
+                    <a:lstStyle/>
+                    <a:p>
+                      <a:pPr>
+                        <a:defRPr sz="1400">
+                          <a:solidFill>
+                            <a:srgbClr val="111827"/>
+                          </a:solidFill>
+                        </a:defRPr>
+                      </a:pPr>
+                      <a:r>
+                        <a:t>Erro mediano</a:t>
+                      </a:r>
+                    </a:p>
+                  </a:txBody>
+                  <a:tcPr/>
+                </a:tc>
+                <a:tc>
+                  <a:txBody>
+                    <a:bodyPr/>
+                    <a:lstStyle/>
+                    <a:p>
+                      <a:pPr>
+                        <a:defRPr sz="1400">
+                          <a:solidFill>
+                            <a:srgbClr val="111827"/>
+                          </a:solidFill>
+                        </a:defRPr>
+                      </a:pPr>
+                      <a:r>
+                        <a:t>~0,6 m</a:t>
+                      </a:r>
+                    </a:p>
+                  </a:txBody>
+                  <a:tcPr/>
+                </a:tc>
+              </a:tr>
+              <a:tr h="365760">
+                <a:tc>
+                  <a:txBody>
+                    <a:bodyPr/>
+                    <a:lstStyle/>
+                    <a:p>
+                      <a:pPr>
+                        <a:defRPr sz="1400">
+                          <a:solidFill>
+                            <a:srgbClr val="111827"/>
+                          </a:solidFill>
+                        </a:defRPr>
+                      </a:pPr>
+                      <a:r>
+                        <a:t>Erro máximo</a:t>
+                      </a:r>
+                    </a:p>
+                  </a:txBody>
+                  <a:tcPr/>
+                </a:tc>
+                <a:tc>
+                  <a:txBody>
+                    <a:bodyPr/>
+                    <a:lstStyle/>
+                    <a:p>
+                      <a:pPr>
+                        <a:defRPr sz="1400">
+                          <a:solidFill>
+                            <a:srgbClr val="111827"/>
+                          </a:solidFill>
+                        </a:defRPr>
+                      </a:pPr>
+                      <a:r>
+                        <a:t>~0,95 m</a:t>
+                      </a:r>
+                    </a:p>
+                  </a:txBody>
+                  <a:tcPr/>
+                </a:tc>
+              </a:tr>
+              <a:tr h="365760">
+                <a:tc>
+                  <a:txBody>
+                    <a:bodyPr/>
+                    <a:lstStyle/>
+                    <a:p>
+                      <a:pPr>
+                        <a:defRPr sz="1400">
+                          <a:solidFill>
+                            <a:srgbClr val="111827"/>
+                          </a:solidFill>
+                        </a:defRPr>
+                      </a:pPr>
+                      <a:r>
+                        <a:t>Taxa de acerto (≤ 2 m)</a:t>
+                      </a:r>
+                    </a:p>
+                  </a:txBody>
+                  <a:tcPr/>
+                </a:tc>
+                <a:tc>
+                  <a:txBody>
+                    <a:bodyPr/>
+                    <a:lstStyle/>
+                    <a:p>
+                      <a:pPr>
+                        <a:defRPr sz="1400">
+                          <a:solidFill>
+                            <a:srgbClr val="111827"/>
+                          </a:solidFill>
+                        </a:defRPr>
+                      </a:pPr>
+                      <a:r>
+                        <a:t>100%</a:t>
+                      </a:r>
+                    </a:p>
+                  </a:txBody>
+                  <a:tcPr/>
+                </a:tc>
+              </a:tr>
+              <a:tr h="365760">
+                <a:tc>
+                  <a:txBody>
+                    <a:bodyPr/>
+                    <a:lstStyle/>
+                    <a:p>
+                      <a:pPr>
+                        <a:defRPr sz="1400">
+                          <a:solidFill>
+                            <a:srgbClr val="111827"/>
+                          </a:solidFill>
+                        </a:defRPr>
+                      </a:pPr>
+                      <a:r>
+                        <a:t>Backend de embedding</a:t>
+                      </a:r>
+                    </a:p>
+                  </a:txBody>
+                  <a:tcPr/>
+                </a:tc>
+                <a:tc>
+                  <a:txBody>
+                    <a:bodyPr/>
+                    <a:lstStyle/>
+                    <a:p>
+                      <a:pPr>
+                        <a:defRPr sz="1400">
+                          <a:solidFill>
+                            <a:srgbClr val="111827"/>
+                          </a:solidFill>
+                        </a:defRPr>
+                      </a:pPr>
+                      <a:r>
+                        <a:t>tiny-image (512-d); DINOv2 plugável (M+)</a:t>
+                      </a:r>
+                    </a:p>
+                  </a:txBody>
+                  <a:tcPr/>
+                </a:tc>
+              </a:tr>
+            </a:tbl>
+          </a:graphicData>
+        </a:graphic>
+      </p:graphicFrame>
+    </p:spTree>
+  </p:cSld>
+  <p:clrMapOvr>
+    <a:masterClrMapping/>
+  </p:clrMapOvr>
+</p:sld>
+</file>
+
+<file path=ppt/slides/slide12.xml><?xml version="1.0" encoding="utf-8"?>
 <p:sld xmlns:a="http://schemas.openxmlformats.org/drawingml/2006/main" xmlns:p="http://schemas.openxmlformats.org/presentationml/2006/main" xmlns:r="http://schemas.openxmlformats.org/officeDocument/2006/relationships">
   <p:cSld>
     <p:bg>
@@ -3548,7 +3884,7 @@
                         </a:defRPr>
                       </a:pPr>
                       <a:r>
-                        <a:t>M1</a:t>
+                        <a:t>M1 ✓</a:t>
                       </a:r>
                     </a:p>
                   </a:txBody>
@@ -3588,7 +3924,7 @@
                         </a:defRPr>
                       </a:pPr>
                       <a:r>
-                        <a:t>M2</a:t>
+                        <a:t>M2 ✓</a:t>
                       </a:r>
                     </a:p>
                   </a:txBody>
@@ -3628,7 +3964,7 @@
                         </a:defRPr>
                       </a:pPr>
                       <a:r>
-                        <a:t>M3</a:t>
+                        <a:t>M3 ✓</a:t>
                       </a:r>
                     </a:p>
                   </a:txBody>
@@ -3668,7 +4004,7 @@
                         </a:defRPr>
                       </a:pPr>
                       <a:r>
-                        <a:t>M4</a:t>
+                        <a:t>M4 ✓</a:t>
                       </a:r>
                     </a:p>
                   </a:txBody>
@@ -3687,7 +4023,7 @@
                         </a:defRPr>
                       </a:pPr>
                       <a:r>
-                        <a:t>Avaliação: métricas de erro (metros) e ajuste do modelo</a:t>
+                        <a:t>Avaliação: métricas de erro (metros) e relatório</a:t>
                       </a:r>
                     </a:p>
                   </a:txBody>
@@ -3706,7 +4042,7 @@
 </p:sld>
 </file>
 
-<file path=ppt/slides/slide12.xml><?xml version="1.0" encoding="utf-8"?>
+<file path=ppt/slides/slide13.xml><?xml version="1.0" encoding="utf-8"?>
 <p:sld xmlns:a="http://schemas.openxmlformats.org/drawingml/2006/main" xmlns:p="http://schemas.openxmlformats.org/presentationml/2006/main" xmlns:r="http://schemas.openxmlformats.org/officeDocument/2006/relationships">
   <p:cSld>
     <p:bg>
@@ -3754,7 +4090,7 @@
               </a:defRPr>
             </a:pPr>
             <a:r>
-              <a:t>Obrigado!  Próximo passo: M1 — Cadastro de locais e plantas</a:t>
+              <a:t>Obrigado!  Próximos passos: Cloudflare Tunnel, embeddings fortes e dados reais</a:t>
             </a:r>
           </a:p>
         </p:txBody>

</xml_diff>